<commit_message>
Agent teams on ADK: coordinators route each turn to specialists (shopper: catalog, navigation, cart; owner: inventory planner, customers and offers, data connector, store ops), owner briefing runs two scouts in parallel then a writer; tools, rules, voice bridge and UI contract unchanged; routing labels in the chat; design note, security row, README and deck updated
Co-Authored-By: Claude Fable 5.1 <noreply@anthropic.com>
</commit_message>
<xml_diff>
--- a/Royal Stack | AI Builder Cup submission.pptx
+++ b/Royal Stack | AI Builder Cup submission.pptx
@@ -10756,7 +10756,7 @@
                 </a:solidFill>
                 <a:latin typeface="Google Sans Flex"/>
               </a:rPr>
-              <a:t>Stock, prices and locations come only from tool results, never from the model's memory</a:t>
+              <a:t>Coordinators only route; specialists only act through tools; stock, prices and locations come from tool results, never from memory</a:t>
             </a:r>
           </a:p>
           <a:p>
@@ -12173,7 +12173,7 @@
                 </a:solidFill>
                 <a:latin typeface="Google Sans Flex"/>
               </a:rPr>
-              <a:t>Most retail AI is a chatbot on one channel. This is one agent on three surfaces: in store, online and the owner's desk, all on one stock record.</a:t>
+              <a:t>Most retail AI is a chatbot on one channel. This is a multi-agent system on Google ADK: coordinators route to specialist agents across three surfaces, in store, online and the owner's desk, all on one stock record.</a:t>
             </a:r>
           </a:p>
           <a:p>
@@ -14030,7 +14030,7 @@
                 </a:solidFill>
                 <a:latin typeface="Google Sans Flex"/>
               </a:rPr>
-              <a:t>Every answer comes from a tool call on the live catalog: search, stock, location, cart, offers, facts. The screen renders tool results only. Out of stock is said plainly with alternatives; "10 kg" becomes two 5 kg packs.</a:t>
+              <a:t>A coordinator agent routes each turn to a specialist (catalog, navigation, cart); every answer comes from a tool call on the live catalog, and the screen renders tool results only. Out of stock is said plainly with alternatives; "10 kg" becomes two 5 kg packs.</a:t>
             </a:r>
           </a:p>
         </p:txBody>
@@ -14518,7 +14518,7 @@
                 </a:solidFill>
                 <a:latin typeface="Google Sans Flex"/>
               </a:rPr>
-              <a:t>Demand signals and loss view</a:t>
+              <a:t>Briefing: two scouts in parallel, one writer</a:t>
             </a:r>
           </a:p>
         </p:txBody>
@@ -19221,7 +19221,7 @@
                 </a:solidFill>
                 <a:latin typeface="Google Sans Flex"/>
               </a:rPr>
-              <a:t>Cloud Run: FastAPI + Google ADK agent runtime</a:t>
+              <a:t>Cloud Run: FastAPI + Google ADK agent teams</a:t>
             </a:r>
           </a:p>
           <a:p>
@@ -19238,7 +19238,7 @@
                 </a:solidFill>
                 <a:latin typeface="Google Sans Flex"/>
               </a:rPr>
-              <a:t>Shopper, owner and connector agents: tools are plain functions gated by mode; the UI renders only tool results</a:t>
+              <a:t>Coordinator agents route each turn to specialists (shopper: catalog, navigation, cart; owner: inventory planner, customers and offers, data connector, store ops); the owner briefing runs two scouts in parallel then a writer; research and mapping agents are called as tools</a:t>
             </a:r>
           </a:p>
           <a:p>
@@ -20251,7 +20251,7 @@
                 </a:solidFill>
                 <a:latin typeface="Google Sans Flex"/>
               </a:rPr>
-              <a:t>Google ADK 2.12 agent runtime</a:t>
+              <a:t>Google ADK 2.12: coordinator, specialist, parallel and sequential agents</a:t>
             </a:r>
           </a:p>
           <a:p>

</xml_diff>

<commit_message>
Deck: problem statement named 'Retail & Commerce: Intelligent Customer and Business Experiences' on the team and criteria slides and in the PDF metadata
Co-Authored-By: Claude Fable 5.1 <noreply@anthropic.com>
</commit_message>
<xml_diff>
--- a/Royal Stack | AI Builder Cup submission.pptx
+++ b/Royal Stack | AI Builder Cup submission.pptx
@@ -7047,7 +7047,7 @@
                 <a:cs typeface="Google Sans Flex"/>
                 <a:sym typeface="Google Sans Flex"/>
               </a:rPr>
-              <a:t>Retail &amp; Commerce. Small and mid-size Indian retailers run on billing software: shoppers get no help in the aisle, owners guess their reorders, and nothing is connected. Royal Stack is one AI commerce agent on one inventory truth, serving the store visit, the online shop and the owner's dashboard.</a:t>
+              <a:t>Retail &amp; Commerce: Intelligent Customer and Business Experiences. Small and mid-size Indian retailers run on billing software: shoppers get no help in the aisle, owners guess their reorders, and nothing is connected. Royal Stack is one AI commerce agent on one inventory truth, serving the store visit, the online shop and the owner's dashboard.</a:t>
             </a:r>
           </a:p>
           <a:p>
@@ -11164,7 +11164,7 @@
                 </a:solidFill>
                 <a:latin typeface="Google Sans Flex"/>
               </a:rPr>
-              <a:t>Retail &amp; Commerce: small and mid-size Indian retailers that already run billing software</a:t>
+              <a:t>Retail &amp; Commerce: Intelligent Customer and Business Experiences: small and mid-size Indian retailers that already run billing software</a:t>
             </a:r>
           </a:p>
           <a:p>

</xml_diff>